<commit_message>
Rework the header identity block and update the enterprise-readiness deck
The signed-in user's name and role badges now sit in their own identity
block, so long names and several roles wrap instead of crowding the nav.

Co-Authored-By: Claude Opus 5.5 <noreply@anthropic.com>
</commit_message>
<xml_diff>
--- a/demo-deck/axyntro-enterprise-readiness.pptx
+++ b/demo-deck/axyntro-enterprise-readiness.pptx
@@ -3902,11 +3902,17 @@
           <p:cNvGraphicFramePr>
             <a:graphicFrameLocks noGrp="1"/>
           </p:cNvGraphicFramePr>
-          <p:nvPr/>
+          <p:nvPr>
+            <p:extLst>
+              <p:ext uri="{D42A27DB-BD31-4B8C-83A1-F6EECF244321}">
+                <p14:modId xmlns:p14="http://schemas.microsoft.com/office/powerpoint/2010/main" val="2715127808"/>
+              </p:ext>
+            </p:extLst>
+          </p:nvPr>
         </p:nvGraphicFramePr>
         <p:xfrm>
-          <a:off x="640080" y="1463039"/>
-          <a:ext cx="10881360" cy="3877056"/>
+          <a:off x="626853" y="1463039"/>
+          <a:ext cx="10894587" cy="4779264"/>
         </p:xfrm>
         <a:graphic>
           <a:graphicData uri="http://schemas.openxmlformats.org/drawingml/2006/table">
@@ -3915,7 +3921,7 @@
                 <a:tableStyleId>{5C22544A-7EE6-4342-B048-85BDC9FD1C3A}</a:tableStyleId>
               </a:tblPr>
               <a:tblGrid>
-                <a:gridCol w="3627120">
+                <a:gridCol w="3640347">
                   <a:extLst>
                     <a:ext uri="{9D8B030D-6E8A-4147-A177-3AD203B41FA5}">
                       <a16:colId xmlns:a16="http://schemas.microsoft.com/office/drawing/2014/main" val="20000"/>
@@ -4014,7 +4020,7 @@
                     <a:lstStyle/>
                     <a:p>
                       <a:r>
-                        <a:rPr sz="1000">
+                        <a:rPr sz="1400">
                           <a:solidFill>
                             <a:srgbClr val="3B4A75"/>
                           </a:solidFill>
@@ -4035,7 +4041,7 @@
                     <a:lstStyle/>
                     <a:p>
                       <a:r>
-                        <a:rPr sz="1000">
+                        <a:rPr sz="1400">
                           <a:solidFill>
                             <a:srgbClr val="3B4A75"/>
                           </a:solidFill>
@@ -4056,7 +4062,7 @@
                     <a:lstStyle/>
                     <a:p>
                       <a:r>
-                        <a:rPr sz="1000">
+                        <a:rPr sz="1400">
                           <a:solidFill>
                             <a:srgbClr val="3B4A75"/>
                           </a:solidFill>
@@ -4084,7 +4090,7 @@
                     <a:lstStyle/>
                     <a:p>
                       <a:r>
-                        <a:rPr sz="1000">
+                        <a:rPr sz="1400">
                           <a:solidFill>
                             <a:srgbClr val="3B4A75"/>
                           </a:solidFill>
@@ -4105,7 +4111,7 @@
                     <a:lstStyle/>
                     <a:p>
                       <a:r>
-                        <a:rPr sz="1000">
+                        <a:rPr sz="1400">
                           <a:solidFill>
                             <a:srgbClr val="3B4A75"/>
                           </a:solidFill>
@@ -4126,7 +4132,7 @@
                     <a:lstStyle/>
                     <a:p>
                       <a:r>
-                        <a:rPr sz="1000">
+                        <a:rPr sz="1400">
                           <a:solidFill>
                             <a:srgbClr val="3B4A75"/>
                           </a:solidFill>
@@ -4154,7 +4160,7 @@
                     <a:lstStyle/>
                     <a:p>
                       <a:r>
-                        <a:rPr sz="1000">
+                        <a:rPr sz="1400">
                           <a:solidFill>
                             <a:srgbClr val="3B4A75"/>
                           </a:solidFill>
@@ -4175,7 +4181,7 @@
                     <a:lstStyle/>
                     <a:p>
                       <a:r>
-                        <a:rPr sz="1000">
+                        <a:rPr sz="1400">
                           <a:solidFill>
                             <a:srgbClr val="3B4A75"/>
                           </a:solidFill>
@@ -4196,7 +4202,7 @@
                     <a:lstStyle/>
                     <a:p>
                       <a:r>
-                        <a:rPr sz="1000">
+                        <a:rPr sz="1400">
                           <a:solidFill>
                             <a:srgbClr val="3B4A75"/>
                           </a:solidFill>
@@ -4224,7 +4230,7 @@
                     <a:lstStyle/>
                     <a:p>
                       <a:r>
-                        <a:rPr sz="1000">
+                        <a:rPr sz="1400">
                           <a:solidFill>
                             <a:srgbClr val="3B4A75"/>
                           </a:solidFill>
@@ -4245,7 +4251,7 @@
                     <a:lstStyle/>
                     <a:p>
                       <a:r>
-                        <a:rPr sz="1000">
+                        <a:rPr sz="1400">
                           <a:solidFill>
                             <a:srgbClr val="3B4A75"/>
                           </a:solidFill>
@@ -4266,7 +4272,7 @@
                     <a:lstStyle/>
                     <a:p>
                       <a:r>
-                        <a:rPr sz="1000">
+                        <a:rPr sz="1400">
                           <a:solidFill>
                             <a:srgbClr val="3B4A75"/>
                           </a:solidFill>
@@ -4294,7 +4300,7 @@
                     <a:lstStyle/>
                     <a:p>
                       <a:r>
-                        <a:rPr sz="1000">
+                        <a:rPr sz="1400">
                           <a:solidFill>
                             <a:srgbClr val="3B4A75"/>
                           </a:solidFill>
@@ -4315,7 +4321,7 @@
                     <a:lstStyle/>
                     <a:p>
                       <a:r>
-                        <a:rPr sz="1000">
+                        <a:rPr sz="1400">
                           <a:solidFill>
                             <a:srgbClr val="3B4A75"/>
                           </a:solidFill>
@@ -4336,7 +4342,7 @@
                     <a:lstStyle/>
                     <a:p>
                       <a:r>
-                        <a:rPr sz="1000">
+                        <a:rPr sz="1400">
                           <a:solidFill>
                             <a:srgbClr val="3B4A75"/>
                           </a:solidFill>
@@ -4364,7 +4370,7 @@
                     <a:lstStyle/>
                     <a:p>
                       <a:r>
-                        <a:rPr sz="1000">
+                        <a:rPr sz="1400">
                           <a:solidFill>
                             <a:srgbClr val="3B4A75"/>
                           </a:solidFill>
@@ -4385,7 +4391,7 @@
                     <a:lstStyle/>
                     <a:p>
                       <a:r>
-                        <a:rPr sz="1000">
+                        <a:rPr sz="1400">
                           <a:solidFill>
                             <a:srgbClr val="3B4A75"/>
                           </a:solidFill>
@@ -4406,7 +4412,7 @@
                     <a:lstStyle/>
                     <a:p>
                       <a:r>
-                        <a:rPr sz="1000">
+                        <a:rPr sz="1400" dirty="0">
                           <a:solidFill>
                             <a:srgbClr val="3B4A75"/>
                           </a:solidFill>
@@ -4434,7 +4440,7 @@
                     <a:lstStyle/>
                     <a:p>
                       <a:r>
-                        <a:rPr sz="1000">
+                        <a:rPr sz="1400">
                           <a:solidFill>
                             <a:srgbClr val="3B4A75"/>
                           </a:solidFill>
@@ -4455,7 +4461,7 @@
                     <a:lstStyle/>
                     <a:p>
                       <a:r>
-                        <a:rPr sz="1000">
+                        <a:rPr sz="1400">
                           <a:solidFill>
                             <a:srgbClr val="3B4A75"/>
                           </a:solidFill>
@@ -4476,7 +4482,7 @@
                     <a:lstStyle/>
                     <a:p>
                       <a:r>
-                        <a:rPr sz="1000">
+                        <a:rPr sz="1400">
                           <a:solidFill>
                             <a:srgbClr val="3B4A75"/>
                           </a:solidFill>
@@ -4504,7 +4510,7 @@
                     <a:lstStyle/>
                     <a:p>
                       <a:r>
-                        <a:rPr sz="1000">
+                        <a:rPr sz="1400">
                           <a:solidFill>
                             <a:srgbClr val="3B4A75"/>
                           </a:solidFill>
@@ -4525,7 +4531,7 @@
                     <a:lstStyle/>
                     <a:p>
                       <a:r>
-                        <a:rPr sz="1000">
+                        <a:rPr sz="1400">
                           <a:solidFill>
                             <a:srgbClr val="3B4A75"/>
                           </a:solidFill>
@@ -4546,7 +4552,7 @@
                     <a:lstStyle/>
                     <a:p>
                       <a:r>
-                        <a:rPr sz="1000">
+                        <a:rPr sz="1400">
                           <a:solidFill>
                             <a:srgbClr val="3B4A75"/>
                           </a:solidFill>
@@ -4574,7 +4580,7 @@
                     <a:lstStyle/>
                     <a:p>
                       <a:r>
-                        <a:rPr sz="1000">
+                        <a:rPr sz="1400">
                           <a:solidFill>
                             <a:srgbClr val="3B4A75"/>
                           </a:solidFill>
@@ -4595,7 +4601,7 @@
                     <a:lstStyle/>
                     <a:p>
                       <a:r>
-                        <a:rPr sz="1000">
+                        <a:rPr sz="1400">
                           <a:solidFill>
                             <a:srgbClr val="3B4A75"/>
                           </a:solidFill>
@@ -4616,7 +4622,7 @@
                     <a:lstStyle/>
                     <a:p>
                       <a:r>
-                        <a:rPr sz="1000">
+                        <a:rPr sz="1400" dirty="0">
                           <a:solidFill>
                             <a:srgbClr val="3B4A75"/>
                           </a:solidFill>
@@ -4748,11 +4754,17 @@
           <p:cNvGraphicFramePr>
             <a:graphicFrameLocks noGrp="1"/>
           </p:cNvGraphicFramePr>
-          <p:nvPr/>
+          <p:nvPr>
+            <p:extLst>
+              <p:ext uri="{D42A27DB-BD31-4B8C-83A1-F6EECF244321}">
+                <p14:modId xmlns:p14="http://schemas.microsoft.com/office/powerpoint/2010/main" val="142920503"/>
+              </p:ext>
+            </p:extLst>
+          </p:nvPr>
         </p:nvGraphicFramePr>
         <p:xfrm>
           <a:off x="640080" y="1463039"/>
-          <a:ext cx="10881360" cy="3072384"/>
+          <a:ext cx="10881360" cy="3267456"/>
         </p:xfrm>
         <a:graphic>
           <a:graphicData uri="http://schemas.openxmlformats.org/drawingml/2006/table">
@@ -4860,7 +4872,7 @@
                     <a:lstStyle/>
                     <a:p>
                       <a:r>
-                        <a:rPr sz="1000">
+                        <a:rPr sz="1600" dirty="0">
                           <a:solidFill>
                             <a:srgbClr val="3B4A75"/>
                           </a:solidFill>
@@ -4881,7 +4893,7 @@
                     <a:lstStyle/>
                     <a:p>
                       <a:r>
-                        <a:rPr sz="1000">
+                        <a:rPr sz="1600">
                           <a:solidFill>
                             <a:srgbClr val="3B4A75"/>
                           </a:solidFill>
@@ -4902,7 +4914,7 @@
                     <a:lstStyle/>
                     <a:p>
                       <a:r>
-                        <a:rPr sz="1000">
+                        <a:rPr sz="1600">
                           <a:solidFill>
                             <a:srgbClr val="3B4A75"/>
                           </a:solidFill>
@@ -4930,7 +4942,7 @@
                     <a:lstStyle/>
                     <a:p>
                       <a:r>
-                        <a:rPr sz="1000">
+                        <a:rPr sz="1600">
                           <a:solidFill>
                             <a:srgbClr val="3B4A75"/>
                           </a:solidFill>
@@ -4951,7 +4963,7 @@
                     <a:lstStyle/>
                     <a:p>
                       <a:r>
-                        <a:rPr sz="1000">
+                        <a:rPr sz="1600">
                           <a:solidFill>
                             <a:srgbClr val="3B4A75"/>
                           </a:solidFill>
@@ -4972,7 +4984,7 @@
                     <a:lstStyle/>
                     <a:p>
                       <a:r>
-                        <a:rPr sz="1000">
+                        <a:rPr sz="1600">
                           <a:solidFill>
                             <a:srgbClr val="3B4A75"/>
                           </a:solidFill>
@@ -5000,7 +5012,7 @@
                     <a:lstStyle/>
                     <a:p>
                       <a:r>
-                        <a:rPr sz="1000">
+                        <a:rPr sz="1600" dirty="0">
                           <a:solidFill>
                             <a:srgbClr val="3B4A75"/>
                           </a:solidFill>
@@ -5021,7 +5033,7 @@
                     <a:lstStyle/>
                     <a:p>
                       <a:r>
-                        <a:rPr sz="1000">
+                        <a:rPr sz="1600">
                           <a:solidFill>
                             <a:srgbClr val="3B4A75"/>
                           </a:solidFill>
@@ -5042,7 +5054,7 @@
                     <a:lstStyle/>
                     <a:p>
                       <a:r>
-                        <a:rPr sz="1000">
+                        <a:rPr sz="1600">
                           <a:solidFill>
                             <a:srgbClr val="3B4A75"/>
                           </a:solidFill>
@@ -5070,7 +5082,7 @@
                     <a:lstStyle/>
                     <a:p>
                       <a:r>
-                        <a:rPr sz="1000">
+                        <a:rPr sz="1600">
                           <a:solidFill>
                             <a:srgbClr val="3B4A75"/>
                           </a:solidFill>
@@ -5091,7 +5103,7 @@
                     <a:lstStyle/>
                     <a:p>
                       <a:r>
-                        <a:rPr sz="1000">
+                        <a:rPr sz="1600" dirty="0">
                           <a:solidFill>
                             <a:srgbClr val="3B4A75"/>
                           </a:solidFill>
@@ -5112,7 +5124,7 @@
                     <a:lstStyle/>
                     <a:p>
                       <a:r>
-                        <a:rPr sz="1000">
+                        <a:rPr sz="1600">
                           <a:solidFill>
                             <a:srgbClr val="3B4A75"/>
                           </a:solidFill>
@@ -5140,7 +5152,7 @@
                     <a:lstStyle/>
                     <a:p>
                       <a:r>
-                        <a:rPr sz="1000">
+                        <a:rPr sz="1600">
                           <a:solidFill>
                             <a:srgbClr val="3B4A75"/>
                           </a:solidFill>
@@ -5161,7 +5173,7 @@
                     <a:lstStyle/>
                     <a:p>
                       <a:r>
-                        <a:rPr sz="1000">
+                        <a:rPr sz="1600" dirty="0">
                           <a:solidFill>
                             <a:srgbClr val="3B4A75"/>
                           </a:solidFill>
@@ -5182,7 +5194,7 @@
                     <a:lstStyle/>
                     <a:p>
                       <a:r>
-                        <a:rPr sz="1000">
+                        <a:rPr sz="1600">
                           <a:solidFill>
                             <a:srgbClr val="3B4A75"/>
                           </a:solidFill>
@@ -5210,7 +5222,7 @@
                     <a:lstStyle/>
                     <a:p>
                       <a:r>
-                        <a:rPr sz="1000">
+                        <a:rPr sz="1600">
                           <a:solidFill>
                             <a:srgbClr val="3B4A75"/>
                           </a:solidFill>
@@ -5231,7 +5243,7 @@
                     <a:lstStyle/>
                     <a:p>
                       <a:r>
-                        <a:rPr sz="1000">
+                        <a:rPr sz="1600" dirty="0">
                           <a:solidFill>
                             <a:srgbClr val="3B4A75"/>
                           </a:solidFill>
@@ -5252,7 +5264,7 @@
                     <a:lstStyle/>
                     <a:p>
                       <a:r>
-                        <a:rPr sz="1000">
+                        <a:rPr sz="1600">
                           <a:solidFill>
                             <a:srgbClr val="3B4A75"/>
                           </a:solidFill>
@@ -5280,7 +5292,7 @@
                     <a:lstStyle/>
                     <a:p>
                       <a:r>
-                        <a:rPr sz="1000">
+                        <a:rPr sz="1600">
                           <a:solidFill>
                             <a:srgbClr val="3B4A75"/>
                           </a:solidFill>
@@ -5301,7 +5313,7 @@
                     <a:lstStyle/>
                     <a:p>
                       <a:r>
-                        <a:rPr sz="1000">
+                        <a:rPr sz="1600">
                           <a:solidFill>
                             <a:srgbClr val="3B4A75"/>
                           </a:solidFill>
@@ -5322,13 +5334,26 @@
                     <a:lstStyle/>
                     <a:p>
                       <a:r>
-                        <a:rPr sz="1000">
+                        <a:rPr sz="1600" dirty="0">
                           <a:solidFill>
                             <a:srgbClr val="3B4A75"/>
                           </a:solidFill>
                         </a:rPr>
-                        <a:t>Per-tenant budgets, alerts and showback</a:t>
+                        <a:t>Per-tenant budgets, alerts and </a:t>
                       </a:r>
+                      <a:r>
+                        <a:rPr sz="1600" dirty="0" err="1">
+                          <a:solidFill>
+                            <a:srgbClr val="3B4A75"/>
+                          </a:solidFill>
+                        </a:rPr>
+                        <a:t>showback</a:t>
+                      </a:r>
+                      <a:endParaRPr sz="1600" dirty="0">
+                        <a:solidFill>
+                          <a:srgbClr val="3B4A75"/>
+                        </a:solidFill>
+                      </a:endParaRPr>
                     </a:p>
                   </a:txBody>
                   <a:tcPr>
@@ -5605,7 +5630,7 @@
         <p:spPr>
           <a:xfrm>
             <a:off x="822959" y="2651760"/>
-            <a:ext cx="2183130" cy="731520"/>
+            <a:ext cx="2183130" cy="523220"/>
           </a:xfrm>
           <a:prstGeom prst="rect">
             <a:avLst/>
@@ -5619,7 +5644,7 @@
           <a:lstStyle/>
           <a:p>
             <a:r>
-              <a:rPr sz="3000" b="1">
+              <a:rPr sz="2800" b="1" dirty="0">
                 <a:solidFill>
                   <a:srgbClr val="16245C"/>
                 </a:solidFill>
@@ -5753,7 +5778,7 @@
         <p:spPr>
           <a:xfrm>
             <a:off x="3600450" y="2651760"/>
-            <a:ext cx="2183130" cy="731520"/>
+            <a:ext cx="2183130" cy="461665"/>
           </a:xfrm>
           <a:prstGeom prst="rect">
             <a:avLst/>
@@ -5767,7 +5792,7 @@
           <a:lstStyle/>
           <a:p>
             <a:r>
-              <a:rPr sz="3000" b="1">
+              <a:rPr sz="2400" b="1" dirty="0">
                 <a:solidFill>
                   <a:srgbClr val="16245C"/>
                 </a:solidFill>
@@ -5901,7 +5926,7 @@
         <p:spPr>
           <a:xfrm>
             <a:off x="6377940" y="2651760"/>
-            <a:ext cx="2183130" cy="731520"/>
+            <a:ext cx="2183130" cy="461665"/>
           </a:xfrm>
           <a:prstGeom prst="rect">
             <a:avLst/>
@@ -5915,7 +5940,7 @@
           <a:lstStyle/>
           <a:p>
             <a:r>
-              <a:rPr sz="3000" b="1">
+              <a:rPr sz="2400" b="1" dirty="0">
                 <a:solidFill>
                   <a:srgbClr val="16245C"/>
                 </a:solidFill>
@@ -6049,7 +6074,7 @@
         <p:spPr>
           <a:xfrm>
             <a:off x="9155430" y="2651760"/>
-            <a:ext cx="2183130" cy="731520"/>
+            <a:ext cx="2183130" cy="523220"/>
           </a:xfrm>
           <a:prstGeom prst="rect">
             <a:avLst/>
@@ -6063,7 +6088,7 @@
           <a:lstStyle/>
           <a:p>
             <a:r>
-              <a:rPr sz="3000" b="1">
+              <a:rPr sz="2800" b="1" dirty="0">
                 <a:solidFill>
                   <a:srgbClr val="16245C"/>
                 </a:solidFill>
@@ -13564,7 +13589,7 @@
           <a:lstStyle/>
           <a:p>
             <a:r>
-              <a:rPr sz="1200" b="0">
+              <a:rPr lang="en-US" sz="1200" b="0" dirty="0">
                 <a:solidFill>
                   <a:srgbClr val="3B4A75"/>
                 </a:solidFill>
@@ -14870,7 +14895,7 @@
                     <a:lstStyle/>
                     <a:p>
                       <a:r>
-                        <a:rPr sz="1200">
+                        <a:rPr sz="1200" dirty="0">
                           <a:solidFill>
                             <a:srgbClr val="3B4A75"/>
                           </a:solidFill>
@@ -15823,7 +15848,7 @@
           <a:lstStyle/>
           <a:p>
             <a:r>
-              <a:rPr sz="1300" b="0">
+              <a:rPr sz="1300" b="0" dirty="0">
                 <a:solidFill>
                   <a:srgbClr val="DFE7FF"/>
                 </a:solidFill>
@@ -15834,7 +15859,7 @@
           </a:p>
           <a:p>
             <a:r>
-              <a:rPr sz="1300" b="0">
+              <a:rPr sz="1300" b="0" dirty="0">
                 <a:solidFill>
                   <a:srgbClr val="DFE7FF"/>
                 </a:solidFill>
@@ -15845,7 +15870,7 @@
           </a:p>
           <a:p>
             <a:r>
-              <a:rPr sz="1300" b="0">
+              <a:rPr sz="1300" b="0" dirty="0">
                 <a:solidFill>
                   <a:srgbClr val="DFE7FF"/>
                 </a:solidFill>
@@ -15856,7 +15881,7 @@
           </a:p>
           <a:p>
             <a:r>
-              <a:rPr sz="1300" b="0">
+              <a:rPr sz="1300" b="0" dirty="0">
                 <a:solidFill>
                   <a:srgbClr val="DFE7FF"/>
                 </a:solidFill>
@@ -15867,7 +15892,7 @@
           </a:p>
           <a:p>
             <a:r>
-              <a:rPr sz="1300" b="0">
+              <a:rPr sz="1300" b="0" dirty="0">
                 <a:solidFill>
                   <a:srgbClr val="DFE7FF"/>
                 </a:solidFill>

</xml_diff>